<commit_message>
Fix 濱本→濱岡 (Table I) in roster and ballots
User-corrected versions: 濱岡 泰延 様 and 濱岡 俊宏 様 in Table I
had been mistakenly extracted as 濱本 from the seating chart.

Co-Authored-By: Claude Opus 4.7 <noreply@anthropic.com>
Claude-Session: https://claude.ai/code/session_015bCXw1XwjsCQKe2rGxWTfb
</commit_message>
<xml_diff>
--- a/voting_ballots.pptx
+++ b/voting_ballots.pptx
@@ -10274,7 +10274,29 @@
                 <a:ea typeface="Yu Gothic" pitchFamily="34" charset="-122"/>
                 <a:cs typeface="Yu Gothic" pitchFamily="34" charset="-120"/>
               </a:rPr>
-              <a:t>濱本 泰延 様</a:t>
+              <a:t>濱</a:t>
+            </a:r>
+            <a:r>
+              <a:rPr lang="ja-JP" altLang="en-US" sz="2200" b="1" dirty="0">
+                <a:solidFill>
+                  <a:srgbClr val="1F3A5F"/>
+                </a:solidFill>
+                <a:latin typeface="Yu Gothic" pitchFamily="34" charset="0"/>
+                <a:ea typeface="Yu Gothic" pitchFamily="34" charset="-122"/>
+                <a:cs typeface="Yu Gothic" pitchFamily="34" charset="-120"/>
+              </a:rPr>
+              <a:t>岡</a:t>
+            </a:r>
+            <a:r>
+              <a:rPr lang="en-US" sz="2200" b="1" dirty="0">
+                <a:solidFill>
+                  <a:srgbClr val="1F3A5F"/>
+                </a:solidFill>
+                <a:latin typeface="Yu Gothic" pitchFamily="34" charset="0"/>
+                <a:ea typeface="Yu Gothic" pitchFamily="34" charset="-122"/>
+                <a:cs typeface="Yu Gothic" pitchFamily="34" charset="-120"/>
+              </a:rPr>
+              <a:t> 泰延 様</a:t>
             </a:r>
             <a:endParaRPr lang="en-US" sz="2200" dirty="0"/>
           </a:p>
@@ -10466,7 +10488,29 @@
                 <a:ea typeface="Yu Gothic" pitchFamily="34" charset="-122"/>
                 <a:cs typeface="Yu Gothic" pitchFamily="34" charset="-120"/>
               </a:rPr>
-              <a:t>濱本 俊宏 様</a:t>
+              <a:t>濱</a:t>
+            </a:r>
+            <a:r>
+              <a:rPr lang="ja-JP" altLang="en-US" sz="2200" b="1" dirty="0">
+                <a:solidFill>
+                  <a:srgbClr val="1F3A5F"/>
+                </a:solidFill>
+                <a:latin typeface="Yu Gothic" pitchFamily="34" charset="0"/>
+                <a:ea typeface="Yu Gothic" pitchFamily="34" charset="-122"/>
+                <a:cs typeface="Yu Gothic" pitchFamily="34" charset="-120"/>
+              </a:rPr>
+              <a:t>岡</a:t>
+            </a:r>
+            <a:r>
+              <a:rPr lang="en-US" sz="2200" b="1" dirty="0">
+                <a:solidFill>
+                  <a:srgbClr val="1F3A5F"/>
+                </a:solidFill>
+                <a:latin typeface="Yu Gothic" pitchFamily="34" charset="0"/>
+                <a:ea typeface="Yu Gothic" pitchFamily="34" charset="-122"/>
+                <a:cs typeface="Yu Gothic" pitchFamily="34" charset="-120"/>
+              </a:rPr>
+              <a:t> 俊宏 様</a:t>
             </a:r>
             <a:endParaRPr lang="en-US" sz="2200" dirty="0"/>
           </a:p>
@@ -20415,6 +20459,17 @@
               <a:buNone/>
             </a:pPr>
             <a:r>
+              <a:rPr lang="ja-JP" altLang="en-US" sz="2200" b="1" dirty="0">
+                <a:solidFill>
+                  <a:srgbClr val="5A2D3E"/>
+                </a:solidFill>
+                <a:latin typeface="Yu Gothic" pitchFamily="34" charset="0"/>
+                <a:ea typeface="Yu Gothic" pitchFamily="34" charset="-122"/>
+                <a:cs typeface="Yu Gothic" pitchFamily="34" charset="-120"/>
+              </a:rPr>
+              <a:t>濱岡</a:t>
+            </a:r>
+            <a:r>
               <a:rPr lang="en-US" sz="2200" b="1" dirty="0">
                 <a:solidFill>
                   <a:srgbClr val="5A2D3E"/>
@@ -20423,7 +20478,7 @@
                 <a:ea typeface="Yu Gothic" pitchFamily="34" charset="-122"/>
                 <a:cs typeface="Yu Gothic" pitchFamily="34" charset="-120"/>
               </a:rPr>
-              <a:t>濱本 泰延 様</a:t>
+              <a:t> 泰延 様</a:t>
             </a:r>
             <a:endParaRPr lang="en-US" sz="2200" dirty="0"/>
           </a:p>
@@ -20607,6 +20662,17 @@
               <a:buNone/>
             </a:pPr>
             <a:r>
+              <a:rPr lang="ja-JP" altLang="en-US" sz="2200" b="1" dirty="0">
+                <a:solidFill>
+                  <a:srgbClr val="5A2D3E"/>
+                </a:solidFill>
+                <a:latin typeface="Yu Gothic" pitchFamily="34" charset="0"/>
+                <a:ea typeface="Yu Gothic" pitchFamily="34" charset="-122"/>
+                <a:cs typeface="Yu Gothic" pitchFamily="34" charset="-120"/>
+              </a:rPr>
+              <a:t>濱岡</a:t>
+            </a:r>
+            <a:r>
               <a:rPr lang="en-US" sz="2200" b="1" dirty="0">
                 <a:solidFill>
                   <a:srgbClr val="5A2D3E"/>
@@ -20615,7 +20681,7 @@
                 <a:ea typeface="Yu Gothic" pitchFamily="34" charset="-122"/>
                 <a:cs typeface="Yu Gothic" pitchFamily="34" charset="-120"/>
               </a:rPr>
-              <a:t>濱本 俊宏 様</a:t>
+              <a:t> 俊宏 様</a:t>
             </a:r>
             <a:endParaRPr lang="en-US" sz="2200" dirty="0"/>
           </a:p>

</xml_diff>